<commit_message>
Fix week 3 slide header, week 9 weights note, week 11 Arabic conditional format
Co-Authored-By: Claude Opus 5.5 <noreply@anthropic.com>
Claude-Session: https://claude.ai/code/session_017bBVjoFFKtzDF1F4iA97k8
</commit_message>
<xml_diff>
--- a/measurement-course/files/w03/en/slides.pptx
+++ b/measurement-course/files/w03/en/slides.pptx
@@ -123,13 +123,13 @@
   <p:extLst>
     <p:ext uri="{521415D9-36F7-43E2-AB2F-B90AF26B5E84}">
       <p14:sectionLst xmlns:p14="http://schemas.microsoft.com/office/powerpoint/2010/main">
-        <p14:section name="Opening" id="{e96a9d42-310e-f0ca-7ec8-1bfecf7b9cbc}">
+        <p14:section name="Opening" id="{8aa3c776-69fd-9529-061f-199e394ada7d}">
           <p14:sldIdLst>
             <p14:sldId id="256"/>
             <p14:sldId id="257"/>
           </p14:sldIdLst>
         </p14:section>
-        <p14:section name="Content" id="{07443f0b-fd75-f49e-0b4c-087cd382a4c2}">
+        <p14:section name="Content" id="{ab956970-e49d-ff26-32f7-08f1bad4b4cb}">
           <p14:sldIdLst>
             <p14:sldId id="258"/>
             <p14:sldId id="259"/>
@@ -147,7 +147,7 @@
             <p14:sldId id="271"/>
           </p14:sldIdLst>
         </p14:section>
-        <p14:section name="Closing" id="{e95bc520-6ced-4fce-1fd3-a1cf89a69a73}">
+        <p14:section name="Closing" id="{495ed531-5700-79ae-dd1a-98378d8e95bd}">
           <p14:sldIdLst>
             <p14:sldId id="272"/>
           </p14:sldIdLst>
@@ -11450,10 +11450,10 @@
             <a:tbl>
               <a:tblPr/>
               <a:tblGrid>
-                <a:gridCol w="1883491"/>
-                <a:gridCol w="1255661"/>
-                <a:gridCol w="4394813"/>
-                <a:gridCol w="3557706"/>
+                <a:gridCol w="1535770"/>
+                <a:gridCol w="1023847"/>
+                <a:gridCol w="5631157"/>
+                <a:gridCol w="2900899"/>
               </a:tblGrid>
               <a:tr h="502920">
                 <a:tc>
@@ -11609,7 +11609,7 @@
                           <a:ea typeface="Calibri" pitchFamily="34" charset="-122"/>
                           <a:cs typeface="Calibri" pitchFamily="34" charset="-120"/>
                         </a:rPr>
-                        <a:t>Intended (TIMSS 2023)</a:t>
+                        <a:t>Intended (teacher's distribution)</a:t>
                       </a:r>
                       <a:endParaRPr lang="en-US" sz="1900" dirty="0">
                         <a:latin typeface="Calibri" charset="0"/>
@@ -12590,7 +12590,7 @@
                 <a:ea typeface="Calibri" pitchFamily="34" charset="-122"/>
                 <a:cs typeface="Calibri" pitchFamily="34" charset="-120"/>
               </a:rPr>
-              <a:t>Reasoning is entirely in one item (item 19).</a:t>
+              <a:t>Reasoning is entirely in one item (item 19). For comparison, TIMSS 2023: 35%, 35% and 30%.</a:t>
             </a:r>
             <a:endParaRPr lang="en-US" sz="1700" dirty="0"/>
           </a:p>

</xml_diff>